<commit_message>
Fix data consistency: email body and attachment now use same values
- Pre-generate shared variables (trust scale, rate, duration, etc.)
  in each email loop, so body text and attachment content reference
  identical numbers instead of independent random values
- Also add GDP/CPI/PMI data to research_macro_1.pdf attachment,
  consistent with email body
- Regenerate all 100 emails and 90+ attachments with seed 42
- Update DEMO.md with actual values from new data

Co-Authored-By: Claude Sonnet 4.6 <noreply@anthropic.com>
</commit_message>
<xml_diff>
--- a/backend/data/attachments/trust_asset_report_5.pptx
+++ b/backend/data/attachments/trust_asset_report_5.pptx
@@ -3188,17 +3188,17 @@
           <a:lstStyle/>
           <a:p>
             <a:r>
-              <a:t>Scale: 324 million RMB</a:t>
-            </a:r>
-          </a:p>
-          <a:p>
-            <a:r>
-              <a:t>Duration: 12 months</a:t>
-            </a:r>
-          </a:p>
-          <a:p>
-            <a:r>
-              <a:t>Expected Return: 8.4% p.a.</a:t>
+              <a:t>Scale: 143.6 million RMB</a:t>
+            </a:r>
+          </a:p>
+          <a:p>
+            <a:r>
+              <a:t>Duration: 24个月</a:t>
+            </a:r>
+          </a:p>
+          <a:p>
+            <a:r>
+              <a:t>Expected Return: 5.49% p.a.</a:t>
             </a:r>
           </a:p>
         </p:txBody>
@@ -3258,17 +3258,17 @@
           <a:lstStyle/>
           <a:p>
             <a:r>
-              <a:t>Senior Tranche: 72%</a:t>
-            </a:r>
-          </a:p>
-          <a:p>
-            <a:r>
-              <a:t>Subordinate Tranche: 22%</a:t>
-            </a:r>
-          </a:p>
-          <a:p>
-            <a:r>
-              <a:t>Risk Mitigation: Land mortgage + Equity pledge</a:t>
+              <a:t>Senior Tranche: 64%</a:t>
+            </a:r>
+          </a:p>
+          <a:p>
+            <a:r>
+              <a:t>Subordinate Tranche: 40%</a:t>
+            </a:r>
+          </a:p>
+          <a:p>
+            <a:r>
+              <a:t>Risk Mitigation: 优先/劣后结构化设计</a:t>
             </a:r>
           </a:p>
         </p:txBody>
@@ -3333,12 +3333,12 @@
           </a:p>
           <a:p>
             <a:r>
-              <a:t>LTV Ratio: 49%</a:t>
-            </a:r>
-          </a:p>
-          <a:p>
-            <a:r>
-              <a:t>Debt Service Coverage: 1.9x</a:t>
+              <a:t>LTV Ratio: 52%</a:t>
+            </a:r>
+          </a:p>
+          <a:p>
+            <a:r>
+              <a:t>Debt Service Coverage: 1.3x</a:t>
             </a:r>
           </a:p>
         </p:txBody>

</xml_diff>